<commit_message>
Add Deepeval et mise à jour Readme
</commit_message>
<xml_diff>
--- a/Ndiaye_Birama_1_Presentation_082026.pptx
+++ b/Ndiaye_Birama_1_Presentation_082026.pptx
@@ -5,7 +5,7 @@
     <p:sldMasterId id="2147483948" r:id="rId1"/>
   </p:sldMasterIdLst>
   <p:notesMasterIdLst>
-    <p:notesMasterId r:id="rId15"/>
+    <p:notesMasterId r:id="rId16"/>
   </p:notesMasterIdLst>
   <p:sldIdLst>
     <p:sldId id="256" r:id="rId2"/>
@@ -19,8 +19,9 @@
     <p:sldId id="282" r:id="rId10"/>
     <p:sldId id="283" r:id="rId11"/>
     <p:sldId id="284" r:id="rId12"/>
-    <p:sldId id="274" r:id="rId13"/>
-    <p:sldId id="275" r:id="rId14"/>
+    <p:sldId id="285" r:id="rId13"/>
+    <p:sldId id="274" r:id="rId14"/>
+    <p:sldId id="275" r:id="rId15"/>
   </p:sldIdLst>
   <p:sldSz cx="12192000" cy="6858000"/>
   <p:notesSz cx="6858000" cy="9144000"/>
@@ -209,7 +210,7 @@
           <a:p>
             <a:fld id="{A651466C-E689-4C50-B043-43C816FDE297}" type="datetimeFigureOut">
               <a:rPr lang="fr-FR" smtClean="0"/>
-              <a:t>16/08/2026</a:t>
+              <a:t>27/08/2026</a:t>
             </a:fld>
             <a:endParaRPr lang="fr-FR"/>
           </a:p>
@@ -755,7 +756,7 @@
           <a:p>
             <a:fld id="{88305DB3-53C6-4905-B45A-5D8DEA6B3707}" type="datetimeFigureOut">
               <a:rPr lang="fr-FR" smtClean="0"/>
-              <a:t>16/08/2026</a:t>
+              <a:t>27/08/2026</a:t>
             </a:fld>
             <a:endParaRPr lang="fr-FR"/>
           </a:p>
@@ -1100,7 +1101,7 @@
           <a:p>
             <a:fld id="{88305DB3-53C6-4905-B45A-5D8DEA6B3707}" type="datetimeFigureOut">
               <a:rPr lang="fr-FR" smtClean="0"/>
-              <a:t>16/08/2026</a:t>
+              <a:t>27/08/2026</a:t>
             </a:fld>
             <a:endParaRPr lang="fr-FR"/>
           </a:p>
@@ -1508,7 +1509,7 @@
           <a:p>
             <a:fld id="{88305DB3-53C6-4905-B45A-5D8DEA6B3707}" type="datetimeFigureOut">
               <a:rPr lang="fr-FR" smtClean="0"/>
-              <a:t>16/08/2026</a:t>
+              <a:t>27/08/2026</a:t>
             </a:fld>
             <a:endParaRPr lang="fr-FR"/>
           </a:p>
@@ -1851,7 +1852,7 @@
           <a:p>
             <a:fld id="{88305DB3-53C6-4905-B45A-5D8DEA6B3707}" type="datetimeFigureOut">
               <a:rPr lang="fr-FR" smtClean="0"/>
-              <a:t>16/08/2026</a:t>
+              <a:t>27/08/2026</a:t>
             </a:fld>
             <a:endParaRPr lang="fr-FR"/>
           </a:p>
@@ -2178,7 +2179,7 @@
           <a:p>
             <a:fld id="{88305DB3-53C6-4905-B45A-5D8DEA6B3707}" type="datetimeFigureOut">
               <a:rPr lang="fr-FR" smtClean="0"/>
-              <a:t>16/08/2026</a:t>
+              <a:t>27/08/2026</a:t>
             </a:fld>
             <a:endParaRPr lang="fr-FR"/>
           </a:p>
@@ -2581,7 +2582,7 @@
           <a:p>
             <a:fld id="{88305DB3-53C6-4905-B45A-5D8DEA6B3707}" type="datetimeFigureOut">
               <a:rPr lang="fr-FR" smtClean="0"/>
-              <a:t>16/08/2026</a:t>
+              <a:t>27/08/2026</a:t>
             </a:fld>
             <a:endParaRPr lang="fr-FR"/>
           </a:p>
@@ -2845,7 +2846,7 @@
           <a:p>
             <a:fld id="{88305DB3-53C6-4905-B45A-5D8DEA6B3707}" type="datetimeFigureOut">
               <a:rPr lang="fr-FR" smtClean="0"/>
-              <a:t>16/08/2026</a:t>
+              <a:t>27/08/2026</a:t>
             </a:fld>
             <a:endParaRPr lang="fr-FR"/>
           </a:p>
@@ -3114,7 +3115,7 @@
           <a:p>
             <a:fld id="{88305DB3-53C6-4905-B45A-5D8DEA6B3707}" type="datetimeFigureOut">
               <a:rPr lang="fr-FR" smtClean="0"/>
-              <a:t>16/08/2026</a:t>
+              <a:t>27/08/2026</a:t>
             </a:fld>
             <a:endParaRPr lang="fr-FR"/>
           </a:p>
@@ -3383,7 +3384,7 @@
           <a:p>
             <a:fld id="{88305DB3-53C6-4905-B45A-5D8DEA6B3707}" type="datetimeFigureOut">
               <a:rPr lang="fr-FR" smtClean="0"/>
-              <a:t>16/08/2026</a:t>
+              <a:t>27/08/2026</a:t>
             </a:fld>
             <a:endParaRPr lang="fr-FR"/>
           </a:p>
@@ -3719,7 +3720,7 @@
           <a:p>
             <a:fld id="{88305DB3-53C6-4905-B45A-5D8DEA6B3707}" type="datetimeFigureOut">
               <a:rPr lang="fr-FR" smtClean="0"/>
-              <a:t>16/08/2026</a:t>
+              <a:t>27/08/2026</a:t>
             </a:fld>
             <a:endParaRPr lang="fr-FR"/>
           </a:p>
@@ -4049,7 +4050,7 @@
           <a:p>
             <a:fld id="{88305DB3-53C6-4905-B45A-5D8DEA6B3707}" type="datetimeFigureOut">
               <a:rPr lang="fr-FR" smtClean="0"/>
-              <a:t>16/08/2026</a:t>
+              <a:t>27/08/2026</a:t>
             </a:fld>
             <a:endParaRPr lang="fr-FR"/>
           </a:p>
@@ -4513,7 +4514,7 @@
           <a:p>
             <a:fld id="{88305DB3-53C6-4905-B45A-5D8DEA6B3707}" type="datetimeFigureOut">
               <a:rPr lang="fr-FR" smtClean="0"/>
-              <a:t>16/08/2026</a:t>
+              <a:t>27/08/2026</a:t>
             </a:fld>
             <a:endParaRPr lang="fr-FR"/>
           </a:p>
@@ -4725,7 +4726,7 @@
           <a:p>
             <a:fld id="{88305DB3-53C6-4905-B45A-5D8DEA6B3707}" type="datetimeFigureOut">
               <a:rPr lang="fr-FR" smtClean="0"/>
-              <a:t>16/08/2026</a:t>
+              <a:t>27/08/2026</a:t>
             </a:fld>
             <a:endParaRPr lang="fr-FR"/>
           </a:p>
@@ -4909,7 +4910,7 @@
           <a:p>
             <a:fld id="{88305DB3-53C6-4905-B45A-5D8DEA6B3707}" type="datetimeFigureOut">
               <a:rPr lang="fr-FR" smtClean="0"/>
-              <a:t>16/08/2026</a:t>
+              <a:t>27/08/2026</a:t>
             </a:fld>
             <a:endParaRPr lang="fr-FR"/>
           </a:p>
@@ -5249,7 +5250,7 @@
           <a:p>
             <a:fld id="{88305DB3-53C6-4905-B45A-5D8DEA6B3707}" type="datetimeFigureOut">
               <a:rPr lang="fr-FR" smtClean="0"/>
-              <a:t>16/08/2026</a:t>
+              <a:t>27/08/2026</a:t>
             </a:fld>
             <a:endParaRPr lang="fr-FR"/>
           </a:p>
@@ -5601,7 +5602,7 @@
           <a:p>
             <a:fld id="{88305DB3-53C6-4905-B45A-5D8DEA6B3707}" type="datetimeFigureOut">
               <a:rPr lang="fr-FR" smtClean="0"/>
-              <a:t>16/08/2026</a:t>
+              <a:t>27/08/2026</a:t>
             </a:fld>
             <a:endParaRPr lang="fr-FR"/>
           </a:p>
@@ -7916,7 +7917,7 @@
           <a:p>
             <a:fld id="{88305DB3-53C6-4905-B45A-5D8DEA6B3707}" type="datetimeFigureOut">
               <a:rPr lang="fr-FR" smtClean="0"/>
-              <a:t>16/08/2026</a:t>
+              <a:t>27/08/2026</a:t>
             </a:fld>
             <a:endParaRPr lang="fr-FR"/>
           </a:p>
@@ -9038,6 +9039,284 @@
           <p:cNvPr id="2" name="Titre 1">
             <a:extLst>
               <a:ext uri="{FF2B5EF4-FFF2-40B4-BE49-F238E27FC236}">
+                <a16:creationId xmlns:a16="http://schemas.microsoft.com/office/drawing/2014/main" id="{908102D0-0D8A-888B-3FE0-1B9B66268AE5}"/>
+              </a:ext>
+            </a:extLst>
+          </p:cNvPr>
+          <p:cNvSpPr>
+            <a:spLocks noGrp="1"/>
+          </p:cNvSpPr>
+          <p:nvPr>
+            <p:ph type="title"/>
+          </p:nvPr>
+        </p:nvSpPr>
+        <p:spPr/>
+        <p:txBody>
+          <a:bodyPr/>
+          <a:lstStyle/>
+          <a:p>
+            <a:r>
+              <a:rPr lang="fr-FR" dirty="0"/>
+              <a:t>Évaluation du RAG avec </a:t>
+            </a:r>
+            <a:r>
+              <a:rPr lang="fr-FR" dirty="0" err="1"/>
+              <a:t>DeepEval</a:t>
+            </a:r>
+            <a:endParaRPr lang="fr-FR" dirty="0"/>
+          </a:p>
+        </p:txBody>
+      </p:sp>
+      <p:sp>
+        <p:nvSpPr>
+          <p:cNvPr id="3" name="Espace réservé du contenu 2">
+            <a:extLst>
+              <a:ext uri="{FF2B5EF4-FFF2-40B4-BE49-F238E27FC236}">
+                <a16:creationId xmlns:a16="http://schemas.microsoft.com/office/drawing/2014/main" id="{D1BBCF55-F029-72CD-95E5-974ECA9A2F3D}"/>
+              </a:ext>
+            </a:extLst>
+          </p:cNvPr>
+          <p:cNvSpPr>
+            <a:spLocks noGrp="1"/>
+          </p:cNvSpPr>
+          <p:nvPr>
+            <p:ph idx="1"/>
+          </p:nvPr>
+        </p:nvSpPr>
+        <p:spPr>
+          <a:xfrm>
+            <a:off x="842482" y="1540189"/>
+            <a:ext cx="10798138" cy="5055820"/>
+          </a:xfrm>
+        </p:spPr>
+        <p:txBody>
+          <a:bodyPr/>
+          <a:lstStyle/>
+          <a:p>
+            <a:r>
+              <a:rPr lang="fr-FR" dirty="0"/>
+              <a:t>Évaluer automatiquement la qualité des réponses du système RAG sur un jeu de </a:t>
+            </a:r>
+            <a:r>
+              <a:rPr lang="fr-FR" b="1" dirty="0"/>
+              <a:t>15 questions représentatives</a:t>
+            </a:r>
+            <a:r>
+              <a:rPr lang="fr-FR" dirty="0"/>
+              <a:t>.</a:t>
+            </a:r>
+          </a:p>
+          <a:p>
+            <a:r>
+              <a:rPr lang="fr-FR" dirty="0"/>
+              <a:t>Création d’un jeu de tests annotés (</a:t>
+            </a:r>
+            <a:r>
+              <a:rPr lang="fr-FR" dirty="0" err="1"/>
+              <a:t>test_dataset.json</a:t>
+            </a:r>
+            <a:r>
+              <a:rPr lang="fr-FR" dirty="0"/>
+              <a:t>)</a:t>
+            </a:r>
+          </a:p>
+          <a:p>
+            <a:r>
+              <a:rPr lang="fr-FR" dirty="0"/>
+              <a:t>Métriques </a:t>
+            </a:r>
+          </a:p>
+          <a:p>
+            <a:pPr lvl="1">
+              <a:buFont typeface="Wingdings" panose="05000000000000000000" pitchFamily="2" charset="2"/>
+              <a:buChar char="Ø"/>
+            </a:pPr>
+            <a:r>
+              <a:rPr lang="fr-FR" sz="1800" dirty="0" err="1"/>
+              <a:t>Answer</a:t>
+            </a:r>
+            <a:r>
+              <a:rPr lang="fr-FR" sz="1800" dirty="0"/>
+              <a:t> </a:t>
+            </a:r>
+            <a:r>
+              <a:rPr lang="fr-FR" sz="1800" dirty="0" err="1"/>
+              <a:t>Relevancy</a:t>
+            </a:r>
+            <a:r>
+              <a:rPr lang="fr-FR" sz="1800" dirty="0"/>
+              <a:t> </a:t>
+            </a:r>
+            <a:r>
+              <a:rPr lang="fr-FR" sz="1800" dirty="0">
+                <a:sym typeface="Wingdings" panose="05000000000000000000" pitchFamily="2" charset="2"/>
+              </a:rPr>
+              <a:t></a:t>
+            </a:r>
+            <a:r>
+              <a:rPr lang="fr-FR" sz="1800" dirty="0"/>
+              <a:t> La réponse répond-elle réellement à la question ?</a:t>
+            </a:r>
+          </a:p>
+          <a:p>
+            <a:pPr lvl="1">
+              <a:buFont typeface="Wingdings" panose="05000000000000000000" pitchFamily="2" charset="2"/>
+              <a:buChar char="Ø"/>
+            </a:pPr>
+            <a:r>
+              <a:rPr lang="fr-FR" sz="1800" dirty="0" err="1"/>
+              <a:t>Faithfulness</a:t>
+            </a:r>
+            <a:r>
+              <a:rPr lang="fr-FR" sz="1800" dirty="0"/>
+              <a:t> </a:t>
+            </a:r>
+            <a:r>
+              <a:rPr lang="fr-FR" sz="1800" dirty="0">
+                <a:sym typeface="Wingdings" panose="05000000000000000000" pitchFamily="2" charset="2"/>
+              </a:rPr>
+              <a:t></a:t>
+            </a:r>
+            <a:r>
+              <a:rPr lang="fr-FR" sz="1800" dirty="0"/>
+              <a:t> La réponse est-elle fidèle aux informations récupérées ?</a:t>
+            </a:r>
+          </a:p>
+          <a:p>
+            <a:pPr lvl="1">
+              <a:buFont typeface="Wingdings" panose="05000000000000000000" pitchFamily="2" charset="2"/>
+              <a:buChar char="Ø"/>
+            </a:pPr>
+            <a:r>
+              <a:rPr lang="fr-FR" sz="1800" dirty="0" err="1"/>
+              <a:t>Contextual</a:t>
+            </a:r>
+            <a:r>
+              <a:rPr lang="fr-FR" sz="1800" dirty="0"/>
+              <a:t> </a:t>
+            </a:r>
+            <a:r>
+              <a:rPr lang="fr-FR" sz="1800" dirty="0" err="1"/>
+              <a:t>Relevancy</a:t>
+            </a:r>
+            <a:r>
+              <a:rPr lang="fr-FR" sz="1800" dirty="0"/>
+              <a:t> </a:t>
+            </a:r>
+            <a:r>
+              <a:rPr lang="fr-FR" sz="1800" dirty="0">
+                <a:sym typeface="Wingdings" panose="05000000000000000000" pitchFamily="2" charset="2"/>
+              </a:rPr>
+              <a:t></a:t>
+            </a:r>
+            <a:r>
+              <a:rPr lang="fr-FR" sz="1800" dirty="0"/>
+              <a:t> Les documents récupérés sont-ils pertinents pour la question ?</a:t>
+            </a:r>
+          </a:p>
+          <a:p>
+            <a:endParaRPr lang="fr-FR" dirty="0"/>
+          </a:p>
+          <a:p>
+            <a:endParaRPr lang="fr-FR" dirty="0"/>
+          </a:p>
+        </p:txBody>
+      </p:sp>
+      <p:pic>
+        <p:nvPicPr>
+          <p:cNvPr id="7" name="Image 6">
+            <a:extLst>
+              <a:ext uri="{FF2B5EF4-FFF2-40B4-BE49-F238E27FC236}">
+                <a16:creationId xmlns:a16="http://schemas.microsoft.com/office/drawing/2014/main" id="{2074C783-A556-37AA-AB81-C90A00AAFD86}"/>
+              </a:ext>
+            </a:extLst>
+          </p:cNvPr>
+          <p:cNvPicPr>
+            <a:picLocks noChangeAspect="1"/>
+          </p:cNvPicPr>
+          <p:nvPr/>
+        </p:nvPicPr>
+        <p:blipFill>
+          <a:blip r:embed="rId2"/>
+          <a:stretch>
+            <a:fillRect/>
+          </a:stretch>
+        </p:blipFill>
+        <p:spPr>
+          <a:xfrm>
+            <a:off x="349965" y="4556276"/>
+            <a:ext cx="4485919" cy="1898313"/>
+          </a:xfrm>
+          <a:prstGeom prst="rect">
+            <a:avLst/>
+          </a:prstGeom>
+        </p:spPr>
+      </p:pic>
+      <p:pic>
+        <p:nvPicPr>
+          <p:cNvPr id="11" name="Image 10">
+            <a:extLst>
+              <a:ext uri="{FF2B5EF4-FFF2-40B4-BE49-F238E27FC236}">
+                <a16:creationId xmlns:a16="http://schemas.microsoft.com/office/drawing/2014/main" id="{BDA3997E-384C-F028-FF5D-8598C5B427D2}"/>
+              </a:ext>
+            </a:extLst>
+          </p:cNvPr>
+          <p:cNvPicPr>
+            <a:picLocks noChangeAspect="1"/>
+          </p:cNvPicPr>
+          <p:nvPr/>
+        </p:nvPicPr>
+        <p:blipFill>
+          <a:blip r:embed="rId3"/>
+          <a:stretch>
+            <a:fillRect/>
+          </a:stretch>
+        </p:blipFill>
+        <p:spPr>
+          <a:xfrm>
+            <a:off x="5109619" y="4556276"/>
+            <a:ext cx="7023518" cy="1973345"/>
+          </a:xfrm>
+          <a:prstGeom prst="rect">
+            <a:avLst/>
+          </a:prstGeom>
+        </p:spPr>
+      </p:pic>
+    </p:spTree>
+    <p:extLst>
+      <p:ext uri="{BB962C8B-B14F-4D97-AF65-F5344CB8AC3E}">
+        <p14:creationId xmlns:p14="http://schemas.microsoft.com/office/powerpoint/2010/main" val="1251159587"/>
+      </p:ext>
+    </p:extLst>
+  </p:cSld>
+  <p:clrMapOvr>
+    <a:masterClrMapping/>
+  </p:clrMapOvr>
+</p:sld>
+</file>
+
+<file path=ppt/slides/slide13.xml><?xml version="1.0" encoding="utf-8"?>
+<p:sld xmlns:a="http://schemas.openxmlformats.org/drawingml/2006/main" xmlns:r="http://schemas.openxmlformats.org/officeDocument/2006/relationships" xmlns:p="http://schemas.openxmlformats.org/presentationml/2006/main">
+  <p:cSld>
+    <p:spTree>
+      <p:nvGrpSpPr>
+        <p:cNvPr id="1" name=""/>
+        <p:cNvGrpSpPr/>
+        <p:nvPr/>
+      </p:nvGrpSpPr>
+      <p:grpSpPr>
+        <a:xfrm>
+          <a:off x="0" y="0"/>
+          <a:ext cx="0" cy="0"/>
+          <a:chOff x="0" y="0"/>
+          <a:chExt cx="0" cy="0"/>
+        </a:xfrm>
+      </p:grpSpPr>
+      <p:sp>
+        <p:nvSpPr>
+          <p:cNvPr id="2" name="Titre 1">
+            <a:extLst>
+              <a:ext uri="{FF2B5EF4-FFF2-40B4-BE49-F238E27FC236}">
                 <a16:creationId xmlns:a16="http://schemas.microsoft.com/office/drawing/2014/main" id="{575F85A7-13C0-D258-ED53-DA6452FD8AC5}"/>
               </a:ext>
             </a:extLst>
@@ -9185,7 +9464,7 @@
 </p:sld>
 </file>
 
-<file path=ppt/slides/slide13.xml><?xml version="1.0" encoding="utf-8"?>
+<file path=ppt/slides/slide14.xml><?xml version="1.0" encoding="utf-8"?>
 <p:sld xmlns:a="http://schemas.openxmlformats.org/drawingml/2006/main" xmlns:r="http://schemas.openxmlformats.org/officeDocument/2006/relationships" xmlns:p="http://schemas.openxmlformats.org/presentationml/2006/main">
   <p:cSld>
     <p:spTree>

</xml_diff>